<commit_message>
chore(docs): replace analyst_workflow.pptx with PowerPoint-repaired version
Co-Authored-By: Claude Opus 4.8 (1M context) <noreply@anthropic.com>
</commit_message>
<xml_diff>
--- a/analyst_workflow.pptx
+++ b/analyst_workflow.pptx
@@ -5,9 +5,9 @@
     <p:sldMasterId id="2147483648" r:id="rId1"/>
   </p:sldMasterIdLst>
   <p:sldIdLst>
-    <p:sldId id="256" r:id="rId7"/>
+    <p:sldId id="256" r:id="rId2"/>
   </p:sldIdLst>
-  <p:sldSz cx="12191695" cy="6858000" type="screen4x3"/>
+  <p:sldSz cx="12192000" cy="6858000"/>
   <p:notesSz cx="6858000" cy="9144000"/>
   <p:defaultTextStyle>
     <a:defPPr>
@@ -104,6 +104,22 @@
       </a:defRPr>
     </a:lvl9pPr>
   </p:defaultTextStyle>
+  <p:extLst>
+    <p:ext uri="{EFAFB233-063F-42B5-8137-9DF3F51BA10A}">
+      <p15:sldGuideLst xmlns:p15="http://schemas.microsoft.com/office/powerpoint/2012/main">
+        <p15:guide id="1" orient="horz" pos="2160">
+          <p15:clr>
+            <a:srgbClr val="A4A3A4"/>
+          </p15:clr>
+        </p15:guide>
+        <p15:guide id="2" pos="2880">
+          <p15:clr>
+            <a:srgbClr val="A4A3A4"/>
+          </p15:clr>
+        </p15:guide>
+      </p15:sldGuideLst>
+    </p:ext>
+  </p:extLst>
 </p:presentation>
 </file>
 
@@ -145,10 +161,9 @@
           <a:lstStyle/>
           <a:p>
             <a:r>
-              <a:rPr lang="en-US" smtClean="0"/>
+              <a:rPr lang="en-US"/>
               <a:t>Click to edit Master title style</a:t>
             </a:r>
-            <a:endParaRPr lang="en-US"/>
           </a:p>
         </p:txBody>
       </p:sp>
@@ -264,10 +279,9 @@
           </a:lstStyle>
           <a:p>
             <a:r>
-              <a:rPr lang="en-US" smtClean="0"/>
+              <a:rPr lang="en-US"/>
               <a:t>Click to edit Master subtitle style</a:t>
             </a:r>
-            <a:endParaRPr lang="en-US"/>
           </a:p>
         </p:txBody>
       </p:sp>
@@ -288,7 +302,7 @@
           <a:p>
             <a:fld id="{5BCAD085-E8A6-8845-BD4E-CB4CCA059FC4}" type="datetimeFigureOut">
               <a:rPr lang="en-US" smtClean="0"/>
-              <a:t>1/27/13</a:t>
+              <a:t>9/29/26</a:t>
             </a:fld>
             <a:endParaRPr lang="en-US"/>
           </a:p>
@@ -382,10 +396,9 @@
           <a:lstStyle/>
           <a:p>
             <a:r>
-              <a:rPr lang="en-US" smtClean="0"/>
+              <a:rPr lang="en-US"/>
               <a:t>Click to edit Master title style</a:t>
             </a:r>
-            <a:endParaRPr lang="en-US"/>
           </a:p>
         </p:txBody>
       </p:sp>
@@ -406,38 +419,37 @@
           <a:p>
             <a:pPr lvl="0"/>
             <a:r>
-              <a:rPr lang="en-US" smtClean="0"/>
+              <a:rPr lang="en-US"/>
               <a:t>Click to edit Master text styles</a:t>
             </a:r>
           </a:p>
           <a:p>
             <a:pPr lvl="1"/>
             <a:r>
-              <a:rPr lang="en-US" smtClean="0"/>
+              <a:rPr lang="en-US"/>
               <a:t>Second level</a:t>
             </a:r>
           </a:p>
           <a:p>
             <a:pPr lvl="2"/>
             <a:r>
-              <a:rPr lang="en-US" smtClean="0"/>
+              <a:rPr lang="en-US"/>
               <a:t>Third level</a:t>
             </a:r>
           </a:p>
           <a:p>
             <a:pPr lvl="3"/>
             <a:r>
-              <a:rPr lang="en-US" smtClean="0"/>
+              <a:rPr lang="en-US"/>
               <a:t>Fourth level</a:t>
             </a:r>
           </a:p>
           <a:p>
             <a:pPr lvl="4"/>
             <a:r>
-              <a:rPr lang="en-US" smtClean="0"/>
+              <a:rPr lang="en-US"/>
               <a:t>Fifth level</a:t>
             </a:r>
-            <a:endParaRPr lang="en-US"/>
           </a:p>
         </p:txBody>
       </p:sp>
@@ -458,7 +470,7 @@
           <a:p>
             <a:fld id="{5BCAD085-E8A6-8845-BD4E-CB4CCA059FC4}" type="datetimeFigureOut">
               <a:rPr lang="en-US" smtClean="0"/>
-              <a:t>1/27/13</a:t>
+              <a:t>9/29/26</a:t>
             </a:fld>
             <a:endParaRPr lang="en-US"/>
           </a:p>
@@ -557,10 +569,9 @@
           <a:lstStyle/>
           <a:p>
             <a:r>
-              <a:rPr lang="en-US" smtClean="0"/>
+              <a:rPr lang="en-US"/>
               <a:t>Click to edit Master title style</a:t>
             </a:r>
-            <a:endParaRPr lang="en-US"/>
           </a:p>
         </p:txBody>
       </p:sp>
@@ -586,38 +597,37 @@
           <a:p>
             <a:pPr lvl="0"/>
             <a:r>
-              <a:rPr lang="en-US" smtClean="0"/>
+              <a:rPr lang="en-US"/>
               <a:t>Click to edit Master text styles</a:t>
             </a:r>
           </a:p>
           <a:p>
             <a:pPr lvl="1"/>
             <a:r>
-              <a:rPr lang="en-US" smtClean="0"/>
+              <a:rPr lang="en-US"/>
               <a:t>Second level</a:t>
             </a:r>
           </a:p>
           <a:p>
             <a:pPr lvl="2"/>
             <a:r>
-              <a:rPr lang="en-US" smtClean="0"/>
+              <a:rPr lang="en-US"/>
               <a:t>Third level</a:t>
             </a:r>
           </a:p>
           <a:p>
             <a:pPr lvl="3"/>
             <a:r>
-              <a:rPr lang="en-US" smtClean="0"/>
+              <a:rPr lang="en-US"/>
               <a:t>Fourth level</a:t>
             </a:r>
           </a:p>
           <a:p>
             <a:pPr lvl="4"/>
             <a:r>
-              <a:rPr lang="en-US" smtClean="0"/>
+              <a:rPr lang="en-US"/>
               <a:t>Fifth level</a:t>
             </a:r>
-            <a:endParaRPr lang="en-US"/>
           </a:p>
         </p:txBody>
       </p:sp>
@@ -638,7 +648,7 @@
           <a:p>
             <a:fld id="{5BCAD085-E8A6-8845-BD4E-CB4CCA059FC4}" type="datetimeFigureOut">
               <a:rPr lang="en-US" smtClean="0"/>
-              <a:t>1/27/13</a:t>
+              <a:t>9/29/26</a:t>
             </a:fld>
             <a:endParaRPr lang="en-US"/>
           </a:p>
@@ -732,10 +742,9 @@
           <a:lstStyle/>
           <a:p>
             <a:r>
-              <a:rPr lang="en-US" smtClean="0"/>
+              <a:rPr lang="en-US"/>
               <a:t>Click to edit Master title style</a:t>
             </a:r>
-            <a:endParaRPr lang="en-US"/>
           </a:p>
         </p:txBody>
       </p:sp>
@@ -756,38 +765,37 @@
           <a:p>
             <a:pPr lvl="0"/>
             <a:r>
-              <a:rPr lang="en-US" smtClean="0"/>
+              <a:rPr lang="en-US"/>
               <a:t>Click to edit Master text styles</a:t>
             </a:r>
           </a:p>
           <a:p>
             <a:pPr lvl="1"/>
             <a:r>
-              <a:rPr lang="en-US" smtClean="0"/>
+              <a:rPr lang="en-US"/>
               <a:t>Second level</a:t>
             </a:r>
           </a:p>
           <a:p>
             <a:pPr lvl="2"/>
             <a:r>
-              <a:rPr lang="en-US" smtClean="0"/>
+              <a:rPr lang="en-US"/>
               <a:t>Third level</a:t>
             </a:r>
           </a:p>
           <a:p>
             <a:pPr lvl="3"/>
             <a:r>
-              <a:rPr lang="en-US" smtClean="0"/>
+              <a:rPr lang="en-US"/>
               <a:t>Fourth level</a:t>
             </a:r>
           </a:p>
           <a:p>
             <a:pPr lvl="4"/>
             <a:r>
-              <a:rPr lang="en-US" smtClean="0"/>
+              <a:rPr lang="en-US"/>
               <a:t>Fifth level</a:t>
             </a:r>
-            <a:endParaRPr lang="en-US"/>
           </a:p>
         </p:txBody>
       </p:sp>
@@ -808,7 +816,7 @@
           <a:p>
             <a:fld id="{5BCAD085-E8A6-8845-BD4E-CB4CCA059FC4}" type="datetimeFigureOut">
               <a:rPr lang="en-US" smtClean="0"/>
-              <a:t>1/27/13</a:t>
+              <a:t>9/29/26</a:t>
             </a:fld>
             <a:endParaRPr lang="en-US"/>
           </a:p>
@@ -911,10 +919,9 @@
           </a:lstStyle>
           <a:p>
             <a:r>
-              <a:rPr lang="en-US" smtClean="0"/>
+              <a:rPr lang="en-US"/>
               <a:t>Click to edit Master title style</a:t>
             </a:r>
-            <a:endParaRPr lang="en-US"/>
           </a:p>
         </p:txBody>
       </p:sp>
@@ -1031,7 +1038,7 @@
           <a:p>
             <a:pPr lvl="0"/>
             <a:r>
-              <a:rPr lang="en-US" smtClean="0"/>
+              <a:rPr lang="en-US"/>
               <a:t>Click to edit Master text styles</a:t>
             </a:r>
           </a:p>
@@ -1054,7 +1061,7 @@
           <a:p>
             <a:fld id="{5BCAD085-E8A6-8845-BD4E-CB4CCA059FC4}" type="datetimeFigureOut">
               <a:rPr lang="en-US" smtClean="0"/>
-              <a:t>1/27/13</a:t>
+              <a:t>9/29/26</a:t>
             </a:fld>
             <a:endParaRPr lang="en-US"/>
           </a:p>
@@ -1148,10 +1155,9 @@
           <a:lstStyle/>
           <a:p>
             <a:r>
-              <a:rPr lang="en-US" smtClean="0"/>
+              <a:rPr lang="en-US"/>
               <a:t>Click to edit Master title style</a:t>
             </a:r>
-            <a:endParaRPr lang="en-US"/>
           </a:p>
         </p:txBody>
       </p:sp>
@@ -1205,38 +1211,37 @@
           <a:p>
             <a:pPr lvl="0"/>
             <a:r>
-              <a:rPr lang="en-US" smtClean="0"/>
+              <a:rPr lang="en-US"/>
               <a:t>Click to edit Master text styles</a:t>
             </a:r>
           </a:p>
           <a:p>
             <a:pPr lvl="1"/>
             <a:r>
-              <a:rPr lang="en-US" smtClean="0"/>
+              <a:rPr lang="en-US"/>
               <a:t>Second level</a:t>
             </a:r>
           </a:p>
           <a:p>
             <a:pPr lvl="2"/>
             <a:r>
-              <a:rPr lang="en-US" smtClean="0"/>
+              <a:rPr lang="en-US"/>
               <a:t>Third level</a:t>
             </a:r>
           </a:p>
           <a:p>
             <a:pPr lvl="3"/>
             <a:r>
-              <a:rPr lang="en-US" smtClean="0"/>
+              <a:rPr lang="en-US"/>
               <a:t>Fourth level</a:t>
             </a:r>
           </a:p>
           <a:p>
             <a:pPr lvl="4"/>
             <a:r>
-              <a:rPr lang="en-US" smtClean="0"/>
+              <a:rPr lang="en-US"/>
               <a:t>Fifth level</a:t>
             </a:r>
-            <a:endParaRPr lang="en-US"/>
           </a:p>
         </p:txBody>
       </p:sp>
@@ -1290,38 +1295,37 @@
           <a:p>
             <a:pPr lvl="0"/>
             <a:r>
-              <a:rPr lang="en-US" smtClean="0"/>
+              <a:rPr lang="en-US"/>
               <a:t>Click to edit Master text styles</a:t>
             </a:r>
           </a:p>
           <a:p>
             <a:pPr lvl="1"/>
             <a:r>
-              <a:rPr lang="en-US" smtClean="0"/>
+              <a:rPr lang="en-US"/>
               <a:t>Second level</a:t>
             </a:r>
           </a:p>
           <a:p>
             <a:pPr lvl="2"/>
             <a:r>
-              <a:rPr lang="en-US" smtClean="0"/>
+              <a:rPr lang="en-US"/>
               <a:t>Third level</a:t>
             </a:r>
           </a:p>
           <a:p>
             <a:pPr lvl="3"/>
             <a:r>
-              <a:rPr lang="en-US" smtClean="0"/>
+              <a:rPr lang="en-US"/>
               <a:t>Fourth level</a:t>
             </a:r>
           </a:p>
           <a:p>
             <a:pPr lvl="4"/>
             <a:r>
-              <a:rPr lang="en-US" smtClean="0"/>
+              <a:rPr lang="en-US"/>
               <a:t>Fifth level</a:t>
             </a:r>
-            <a:endParaRPr lang="en-US"/>
           </a:p>
         </p:txBody>
       </p:sp>
@@ -1342,7 +1346,7 @@
           <a:p>
             <a:fld id="{5BCAD085-E8A6-8845-BD4E-CB4CCA059FC4}" type="datetimeFigureOut">
               <a:rPr lang="en-US" smtClean="0"/>
-              <a:t>1/27/13</a:t>
+              <a:t>9/29/26</a:t>
             </a:fld>
             <a:endParaRPr lang="en-US"/>
           </a:p>
@@ -1440,10 +1444,9 @@
           </a:lstStyle>
           <a:p>
             <a:r>
-              <a:rPr lang="en-US" smtClean="0"/>
+              <a:rPr lang="en-US"/>
               <a:t>Click to edit Master title style</a:t>
             </a:r>
-            <a:endParaRPr lang="en-US"/>
           </a:p>
         </p:txBody>
       </p:sp>
@@ -1506,7 +1509,7 @@
           <a:p>
             <a:pPr lvl="0"/>
             <a:r>
-              <a:rPr lang="en-US" smtClean="0"/>
+              <a:rPr lang="en-US"/>
               <a:t>Click to edit Master text styles</a:t>
             </a:r>
           </a:p>
@@ -1562,38 +1565,37 @@
           <a:p>
             <a:pPr lvl="0"/>
             <a:r>
-              <a:rPr lang="en-US" smtClean="0"/>
+              <a:rPr lang="en-US"/>
               <a:t>Click to edit Master text styles</a:t>
             </a:r>
           </a:p>
           <a:p>
             <a:pPr lvl="1"/>
             <a:r>
-              <a:rPr lang="en-US" smtClean="0"/>
+              <a:rPr lang="en-US"/>
               <a:t>Second level</a:t>
             </a:r>
           </a:p>
           <a:p>
             <a:pPr lvl="2"/>
             <a:r>
-              <a:rPr lang="en-US" smtClean="0"/>
+              <a:rPr lang="en-US"/>
               <a:t>Third level</a:t>
             </a:r>
           </a:p>
           <a:p>
             <a:pPr lvl="3"/>
             <a:r>
-              <a:rPr lang="en-US" smtClean="0"/>
+              <a:rPr lang="en-US"/>
               <a:t>Fourth level</a:t>
             </a:r>
           </a:p>
           <a:p>
             <a:pPr lvl="4"/>
             <a:r>
-              <a:rPr lang="en-US" smtClean="0"/>
+              <a:rPr lang="en-US"/>
               <a:t>Fifth level</a:t>
             </a:r>
-            <a:endParaRPr lang="en-US"/>
           </a:p>
         </p:txBody>
       </p:sp>
@@ -1656,7 +1658,7 @@
           <a:p>
             <a:pPr lvl="0"/>
             <a:r>
-              <a:rPr lang="en-US" smtClean="0"/>
+              <a:rPr lang="en-US"/>
               <a:t>Click to edit Master text styles</a:t>
             </a:r>
           </a:p>
@@ -1712,38 +1714,37 @@
           <a:p>
             <a:pPr lvl="0"/>
             <a:r>
-              <a:rPr lang="en-US" smtClean="0"/>
+              <a:rPr lang="en-US"/>
               <a:t>Click to edit Master text styles</a:t>
             </a:r>
           </a:p>
           <a:p>
             <a:pPr lvl="1"/>
             <a:r>
-              <a:rPr lang="en-US" smtClean="0"/>
+              <a:rPr lang="en-US"/>
               <a:t>Second level</a:t>
             </a:r>
           </a:p>
           <a:p>
             <a:pPr lvl="2"/>
             <a:r>
-              <a:rPr lang="en-US" smtClean="0"/>
+              <a:rPr lang="en-US"/>
               <a:t>Third level</a:t>
             </a:r>
           </a:p>
           <a:p>
             <a:pPr lvl="3"/>
             <a:r>
-              <a:rPr lang="en-US" smtClean="0"/>
+              <a:rPr lang="en-US"/>
               <a:t>Fourth level</a:t>
             </a:r>
           </a:p>
           <a:p>
             <a:pPr lvl="4"/>
             <a:r>
-              <a:rPr lang="en-US" smtClean="0"/>
+              <a:rPr lang="en-US"/>
               <a:t>Fifth level</a:t>
             </a:r>
-            <a:endParaRPr lang="en-US"/>
           </a:p>
         </p:txBody>
       </p:sp>
@@ -1764,7 +1765,7 @@
           <a:p>
             <a:fld id="{5BCAD085-E8A6-8845-BD4E-CB4CCA059FC4}" type="datetimeFigureOut">
               <a:rPr lang="en-US" smtClean="0"/>
-              <a:t>1/27/13</a:t>
+              <a:t>9/29/26</a:t>
             </a:fld>
             <a:endParaRPr lang="en-US"/>
           </a:p>
@@ -1858,10 +1859,9 @@
           <a:lstStyle/>
           <a:p>
             <a:r>
-              <a:rPr lang="en-US" smtClean="0"/>
+              <a:rPr lang="en-US"/>
               <a:t>Click to edit Master title style</a:t>
             </a:r>
-            <a:endParaRPr lang="en-US"/>
           </a:p>
         </p:txBody>
       </p:sp>
@@ -1882,7 +1882,7 @@
           <a:p>
             <a:fld id="{5BCAD085-E8A6-8845-BD4E-CB4CCA059FC4}" type="datetimeFigureOut">
               <a:rPr lang="en-US" smtClean="0"/>
-              <a:t>1/27/13</a:t>
+              <a:t>9/29/26</a:t>
             </a:fld>
             <a:endParaRPr lang="en-US"/>
           </a:p>
@@ -1977,7 +1977,7 @@
           <a:p>
             <a:fld id="{5BCAD085-E8A6-8845-BD4E-CB4CCA059FC4}" type="datetimeFigureOut">
               <a:rPr lang="en-US" smtClean="0"/>
-              <a:t>1/27/13</a:t>
+              <a:t>9/29/26</a:t>
             </a:fld>
             <a:endParaRPr lang="en-US"/>
           </a:p>
@@ -2080,10 +2080,9 @@
           </a:lstStyle>
           <a:p>
             <a:r>
-              <a:rPr lang="en-US" smtClean="0"/>
+              <a:rPr lang="en-US"/>
               <a:t>Click to edit Master title style</a:t>
             </a:r>
-            <a:endParaRPr lang="en-US"/>
           </a:p>
         </p:txBody>
       </p:sp>
@@ -2137,38 +2136,37 @@
           <a:p>
             <a:pPr lvl="0"/>
             <a:r>
-              <a:rPr lang="en-US" smtClean="0"/>
+              <a:rPr lang="en-US"/>
               <a:t>Click to edit Master text styles</a:t>
             </a:r>
           </a:p>
           <a:p>
             <a:pPr lvl="1"/>
             <a:r>
-              <a:rPr lang="en-US" smtClean="0"/>
+              <a:rPr lang="en-US"/>
               <a:t>Second level</a:t>
             </a:r>
           </a:p>
           <a:p>
             <a:pPr lvl="2"/>
             <a:r>
-              <a:rPr lang="en-US" smtClean="0"/>
+              <a:rPr lang="en-US"/>
               <a:t>Third level</a:t>
             </a:r>
           </a:p>
           <a:p>
             <a:pPr lvl="3"/>
             <a:r>
-              <a:rPr lang="en-US" smtClean="0"/>
+              <a:rPr lang="en-US"/>
               <a:t>Fourth level</a:t>
             </a:r>
           </a:p>
           <a:p>
             <a:pPr lvl="4"/>
             <a:r>
-              <a:rPr lang="en-US" smtClean="0"/>
+              <a:rPr lang="en-US"/>
               <a:t>Fifth level</a:t>
             </a:r>
-            <a:endParaRPr lang="en-US"/>
           </a:p>
         </p:txBody>
       </p:sp>
@@ -2231,7 +2229,7 @@
           <a:p>
             <a:pPr lvl="0"/>
             <a:r>
-              <a:rPr lang="en-US" smtClean="0"/>
+              <a:rPr lang="en-US"/>
               <a:t>Click to edit Master text styles</a:t>
             </a:r>
           </a:p>
@@ -2254,7 +2252,7 @@
           <a:p>
             <a:fld id="{5BCAD085-E8A6-8845-BD4E-CB4CCA059FC4}" type="datetimeFigureOut">
               <a:rPr lang="en-US" smtClean="0"/>
-              <a:t>1/27/13</a:t>
+              <a:t>9/29/26</a:t>
             </a:fld>
             <a:endParaRPr lang="en-US"/>
           </a:p>
@@ -2357,10 +2355,9 @@
           </a:lstStyle>
           <a:p>
             <a:r>
-              <a:rPr lang="en-US" smtClean="0"/>
+              <a:rPr lang="en-US"/>
               <a:t>Click to edit Master title style</a:t>
             </a:r>
-            <a:endParaRPr lang="en-US"/>
           </a:p>
         </p:txBody>
       </p:sp>
@@ -2484,7 +2481,7 @@
           <a:p>
             <a:pPr lvl="0"/>
             <a:r>
-              <a:rPr lang="en-US" smtClean="0"/>
+              <a:rPr lang="en-US"/>
               <a:t>Click to edit Master text styles</a:t>
             </a:r>
           </a:p>
@@ -2507,7 +2504,7 @@
           <a:p>
             <a:fld id="{5BCAD085-E8A6-8845-BD4E-CB4CCA059FC4}" type="datetimeFigureOut">
               <a:rPr lang="en-US" smtClean="0"/>
-              <a:t>1/27/13</a:t>
+              <a:t>9/29/26</a:t>
             </a:fld>
             <a:endParaRPr lang="en-US"/>
           </a:p>
@@ -2616,10 +2613,9 @@
           <a:lstStyle/>
           <a:p>
             <a:r>
-              <a:rPr lang="en-US" smtClean="0"/>
+              <a:rPr lang="en-US"/>
               <a:t>Click to edit Master title style</a:t>
             </a:r>
-            <a:endParaRPr lang="en-US"/>
           </a:p>
         </p:txBody>
       </p:sp>
@@ -2650,38 +2646,37 @@
           <a:p>
             <a:pPr lvl="0"/>
             <a:r>
-              <a:rPr lang="en-US" smtClean="0"/>
+              <a:rPr lang="en-US"/>
               <a:t>Click to edit Master text styles</a:t>
             </a:r>
           </a:p>
           <a:p>
             <a:pPr lvl="1"/>
             <a:r>
-              <a:rPr lang="en-US" smtClean="0"/>
+              <a:rPr lang="en-US"/>
               <a:t>Second level</a:t>
             </a:r>
           </a:p>
           <a:p>
             <a:pPr lvl="2"/>
             <a:r>
-              <a:rPr lang="en-US" smtClean="0"/>
+              <a:rPr lang="en-US"/>
               <a:t>Third level</a:t>
             </a:r>
           </a:p>
           <a:p>
             <a:pPr lvl="3"/>
             <a:r>
-              <a:rPr lang="en-US" smtClean="0"/>
+              <a:rPr lang="en-US"/>
               <a:t>Fourth level</a:t>
             </a:r>
           </a:p>
           <a:p>
             <a:pPr lvl="4"/>
             <a:r>
-              <a:rPr lang="en-US" smtClean="0"/>
+              <a:rPr lang="en-US"/>
               <a:t>Fifth level</a:t>
             </a:r>
-            <a:endParaRPr lang="en-US"/>
           </a:p>
         </p:txBody>
       </p:sp>
@@ -2720,7 +2715,7 @@
           <a:p>
             <a:fld id="{5BCAD085-E8A6-8845-BD4E-CB4CCA059FC4}" type="datetimeFigureOut">
               <a:rPr lang="en-US" smtClean="0"/>
-              <a:t>1/27/13</a:t>
+              <a:t>9/29/26</a:t>
             </a:fld>
             <a:endParaRPr lang="en-US"/>
           </a:p>
@@ -3079,7 +3074,7 @@
 </file>
 
 <file path=ppt/slides/slide1.xml><?xml version="1.0" encoding="utf-8"?>
-<p:sld xmlns:a="http://schemas.openxmlformats.org/drawingml/2006/main" xmlns:p="http://schemas.openxmlformats.org/presentationml/2006/main" xmlns:r="http://schemas.openxmlformats.org/officeDocument/2006/relationships">
+<p:sld xmlns:a="http://schemas.openxmlformats.org/drawingml/2006/main" xmlns:r="http://schemas.openxmlformats.org/officeDocument/2006/relationships" xmlns:p="http://schemas.openxmlformats.org/presentationml/2006/main">
   <p:cSld>
     <p:spTree>
       <p:nvGrpSpPr>
@@ -3087,7 +3082,14 @@
         <p:cNvGrpSpPr/>
         <p:nvPr/>
       </p:nvGrpSpPr>
-      <p:grpSpPr/>
+      <p:grpSpPr>
+        <a:xfrm>
+          <a:off x="0" y="0"/>
+          <a:ext cx="0" cy="0"/>
+          <a:chOff x="0" y="0"/>
+          <a:chExt cx="0" cy="0"/>
+        </a:xfrm>
+      </p:grpSpPr>
       <p:sp>
         <p:nvSpPr>
           <p:cNvPr id="2" name="Oval 1"/>
@@ -3128,6 +3130,7 @@
           <a:lstStyle/>
           <a:p>
             <a:pPr algn="ctr"/>
+            <a:endParaRPr/>
           </a:p>
         </p:txBody>
       </p:sp>
@@ -3171,6 +3174,7 @@
           <a:lstStyle/>
           <a:p>
             <a:pPr algn="ctr"/>
+            <a:endParaRPr/>
           </a:p>
         </p:txBody>
       </p:sp>
@@ -3191,7 +3195,7 @@
           <a:noFill/>
         </p:spPr>
         <p:txBody>
-          <a:bodyPr wrap="square" lIns="0" rIns="0" tIns="0" bIns="0" anchor="t">
+          <a:bodyPr wrap="square" lIns="0" tIns="0" rIns="0" bIns="0" anchor="t">
             <a:spAutoFit/>
           </a:bodyPr>
           <a:lstStyle/>
@@ -3226,7 +3230,7 @@
           <a:noFill/>
         </p:spPr>
         <p:txBody>
-          <a:bodyPr wrap="square" lIns="0" rIns="0" tIns="0" bIns="0" anchor="t">
+          <a:bodyPr wrap="square" lIns="0" tIns="0" rIns="0" bIns="0" anchor="t">
             <a:spAutoFit/>
           </a:bodyPr>
           <a:lstStyle/>
@@ -3261,7 +3265,7 @@
           <a:noFill/>
         </p:spPr>
         <p:txBody>
-          <a:bodyPr wrap="square" lIns="0" rIns="0" tIns="0" bIns="0" anchor="t">
+          <a:bodyPr wrap="square" lIns="0" tIns="0" rIns="0" bIns="0" anchor="t">
             <a:spAutoFit/>
           </a:bodyPr>
           <a:lstStyle/>
@@ -3323,6 +3327,7 @@
           <a:lstStyle/>
           <a:p>
             <a:pPr algn="ctr"/>
+            <a:endParaRPr/>
           </a:p>
         </p:txBody>
       </p:sp>
@@ -3343,7 +3348,7 @@
           <a:noFill/>
         </p:spPr>
         <p:txBody>
-          <a:bodyPr wrap="square" lIns="0" rIns="0" tIns="0" bIns="0" anchor="t">
+          <a:bodyPr wrap="square" lIns="0" tIns="0" rIns="0" bIns="0" anchor="t">
             <a:spAutoFit/>
           </a:bodyPr>
           <a:lstStyle/>
@@ -3378,7 +3383,7 @@
           <a:noFill/>
         </p:spPr>
         <p:txBody>
-          <a:bodyPr wrap="square" lIns="0" rIns="0" tIns="0" bIns="0" anchor="t">
+          <a:bodyPr wrap="square" lIns="0" tIns="0" rIns="0" bIns="0" anchor="t">
             <a:spAutoFit/>
           </a:bodyPr>
           <a:lstStyle/>
@@ -3480,7 +3485,7 @@
           </a:fontRef>
         </p:style>
         <p:txBody>
-          <a:bodyPr rtlCol="0" anchor="ctr" lIns="0" rIns="0" tIns="0" bIns="0" wrap="square"/>
+          <a:bodyPr wrap="square" lIns="0" tIns="0" rIns="0" bIns="0" rtlCol="0" anchor="ctr"/>
           <a:lstStyle/>
           <a:p>
             <a:pPr algn="ctr"/>
@@ -3513,7 +3518,7 @@
           <a:noFill/>
         </p:spPr>
         <p:txBody>
-          <a:bodyPr wrap="square" lIns="0" rIns="0" tIns="0" bIns="0" anchor="t">
+          <a:bodyPr wrap="square" lIns="0" tIns="0" rIns="0" bIns="0" anchor="t">
             <a:spAutoFit/>
           </a:bodyPr>
           <a:lstStyle/>
@@ -3567,7 +3572,7 @@
           </a:fontRef>
         </p:style>
         <p:txBody>
-          <a:bodyPr rtlCol="0" anchor="ctr" lIns="0" rIns="0" tIns="0" bIns="0" wrap="square"/>
+          <a:bodyPr wrap="square" lIns="0" tIns="0" rIns="0" bIns="0" rtlCol="0" anchor="ctr"/>
           <a:lstStyle/>
           <a:p>
             <a:pPr algn="ctr"/>
@@ -3600,7 +3605,7 @@
           <a:noFill/>
         </p:spPr>
         <p:txBody>
-          <a:bodyPr wrap="square" lIns="0" rIns="0" tIns="0" bIns="0" anchor="t">
+          <a:bodyPr wrap="square" lIns="0" tIns="0" rIns="0" bIns="0" anchor="t">
             <a:spAutoFit/>
           </a:bodyPr>
           <a:lstStyle/>
@@ -3654,7 +3659,7 @@
           </a:fontRef>
         </p:style>
         <p:txBody>
-          <a:bodyPr rtlCol="0" anchor="ctr" lIns="0" rIns="0" tIns="0" bIns="0" wrap="square"/>
+          <a:bodyPr wrap="square" lIns="0" tIns="0" rIns="0" bIns="0" rtlCol="0" anchor="ctr"/>
           <a:lstStyle/>
           <a:p>
             <a:pPr algn="ctr"/>
@@ -3687,7 +3692,7 @@
           <a:noFill/>
         </p:spPr>
         <p:txBody>
-          <a:bodyPr wrap="square" lIns="0" rIns="0" tIns="0" bIns="0" anchor="t">
+          <a:bodyPr wrap="square" lIns="0" tIns="0" rIns="0" bIns="0" anchor="t">
             <a:spAutoFit/>
           </a:bodyPr>
           <a:lstStyle/>
@@ -3713,8 +3718,8 @@
         </p:nvCxnSpPr>
         <p:spPr>
           <a:xfrm>
-            <a:off x="5404104.0" y="978408"/>
-            <a:ext cx="0.0" cy="4005072"/>
+            <a:off x="0" y="978408"/>
+            <a:ext cx="0" cy="4005072"/>
           </a:xfrm>
           <a:prstGeom prst="line">
             <a:avLst/>
@@ -3776,7 +3781,7 @@
           </a:fontRef>
         </p:style>
         <p:txBody>
-          <a:bodyPr rtlCol="0" anchor="ctr" lIns="0" rIns="0" tIns="0" bIns="0" wrap="square"/>
+          <a:bodyPr wrap="square" lIns="0" tIns="0" rIns="0" bIns="0" rtlCol="0" anchor="ctr"/>
           <a:lstStyle/>
           <a:p>
             <a:pPr algn="ctr"/>
@@ -3836,6 +3841,7 @@
           <a:lstStyle/>
           <a:p>
             <a:pPr algn="ctr"/>
+            <a:endParaRPr/>
           </a:p>
         </p:txBody>
       </p:sp>
@@ -3879,6 +3885,7 @@
           <a:lstStyle/>
           <a:p>
             <a:pPr algn="ctr"/>
+            <a:endParaRPr/>
           </a:p>
         </p:txBody>
       </p:sp>
@@ -3899,7 +3906,7 @@
           <a:noFill/>
         </p:spPr>
         <p:txBody>
-          <a:bodyPr wrap="square" lIns="0" rIns="0" tIns="0" bIns="0" anchor="t">
+          <a:bodyPr wrap="square" lIns="0" tIns="0" rIns="0" bIns="0" anchor="t">
             <a:spAutoFit/>
           </a:bodyPr>
           <a:lstStyle/>
@@ -3969,7 +3976,7 @@
           </a:fontRef>
         </p:style>
         <p:txBody>
-          <a:bodyPr rtlCol="0" anchor="ctr" lIns="0" rIns="0" tIns="0" bIns="0" wrap="square"/>
+          <a:bodyPr wrap="square" lIns="0" tIns="0" rIns="0" bIns="0" rtlCol="0" anchor="ctr"/>
           <a:lstStyle/>
           <a:p>
             <a:pPr algn="ctr"/>
@@ -4029,6 +4036,7 @@
           <a:lstStyle/>
           <a:p>
             <a:pPr algn="ctr"/>
+            <a:endParaRPr/>
           </a:p>
         </p:txBody>
       </p:sp>
@@ -4072,6 +4080,7 @@
           <a:lstStyle/>
           <a:p>
             <a:pPr algn="ctr"/>
+            <a:endParaRPr/>
           </a:p>
         </p:txBody>
       </p:sp>
@@ -4092,7 +4101,7 @@
           <a:noFill/>
         </p:spPr>
         <p:txBody>
-          <a:bodyPr wrap="square" lIns="0" rIns="0" tIns="0" bIns="0" anchor="t">
+          <a:bodyPr wrap="square" lIns="0" tIns="0" rIns="0" bIns="0" anchor="t">
             <a:spAutoFit/>
           </a:bodyPr>
           <a:lstStyle/>
@@ -4162,7 +4171,7 @@
           </a:fontRef>
         </p:style>
         <p:txBody>
-          <a:bodyPr rtlCol="0" anchor="ctr" lIns="0" rIns="0" tIns="0" bIns="0" wrap="square"/>
+          <a:bodyPr wrap="square" lIns="0" tIns="0" rIns="0" bIns="0" rtlCol="0" anchor="ctr"/>
           <a:lstStyle/>
           <a:p>
             <a:pPr algn="ctr"/>
@@ -4222,6 +4231,7 @@
           <a:lstStyle/>
           <a:p>
             <a:pPr algn="ctr"/>
+            <a:endParaRPr/>
           </a:p>
         </p:txBody>
       </p:sp>
@@ -4265,6 +4275,7 @@
           <a:lstStyle/>
           <a:p>
             <a:pPr algn="ctr"/>
+            <a:endParaRPr/>
           </a:p>
         </p:txBody>
       </p:sp>
@@ -4285,7 +4296,7 @@
           <a:noFill/>
         </p:spPr>
         <p:txBody>
-          <a:bodyPr wrap="square" lIns="0" rIns="0" tIns="0" bIns="0" anchor="t">
+          <a:bodyPr wrap="square" lIns="0" tIns="0" rIns="0" bIns="0" anchor="t">
             <a:spAutoFit/>
           </a:bodyPr>
           <a:lstStyle/>
@@ -4355,7 +4366,7 @@
           </a:fontRef>
         </p:style>
         <p:txBody>
-          <a:bodyPr rtlCol="0" anchor="ctr" lIns="0" rIns="0" tIns="0" bIns="0" wrap="square"/>
+          <a:bodyPr wrap="square" lIns="0" tIns="0" rIns="0" bIns="0" rtlCol="0" anchor="ctr"/>
           <a:lstStyle/>
           <a:p>
             <a:pPr algn="ctr"/>
@@ -4415,6 +4426,7 @@
           <a:lstStyle/>
           <a:p>
             <a:pPr algn="ctr"/>
+            <a:endParaRPr/>
           </a:p>
         </p:txBody>
       </p:sp>
@@ -4458,6 +4470,7 @@
           <a:lstStyle/>
           <a:p>
             <a:pPr algn="ctr"/>
+            <a:endParaRPr/>
           </a:p>
         </p:txBody>
       </p:sp>
@@ -4478,7 +4491,7 @@
           <a:noFill/>
         </p:spPr>
         <p:txBody>
-          <a:bodyPr wrap="square" lIns="0" rIns="0" tIns="0" bIns="0" anchor="t">
+          <a:bodyPr wrap="square" lIns="0" tIns="0" rIns="0" bIns="0" anchor="t">
             <a:spAutoFit/>
           </a:bodyPr>
           <a:lstStyle/>
@@ -4548,7 +4561,7 @@
           </a:fontRef>
         </p:style>
         <p:txBody>
-          <a:bodyPr rtlCol="0" anchor="ctr" lIns="0" rIns="0" tIns="0" bIns="0" wrap="square"/>
+          <a:bodyPr wrap="square" lIns="0" tIns="0" rIns="0" bIns="0" rtlCol="0" anchor="ctr"/>
           <a:lstStyle/>
           <a:p>
             <a:pPr algn="ctr"/>
@@ -4608,6 +4621,7 @@
           <a:lstStyle/>
           <a:p>
             <a:pPr algn="ctr"/>
+            <a:endParaRPr/>
           </a:p>
         </p:txBody>
       </p:sp>
@@ -4651,6 +4665,7 @@
           <a:lstStyle/>
           <a:p>
             <a:pPr algn="ctr"/>
+            <a:endParaRPr/>
           </a:p>
         </p:txBody>
       </p:sp>
@@ -4671,7 +4686,7 @@
           <a:noFill/>
         </p:spPr>
         <p:txBody>
-          <a:bodyPr wrap="square" lIns="0" rIns="0" tIns="0" bIns="0" anchor="t">
+          <a:bodyPr wrap="square" lIns="0" tIns="0" rIns="0" bIns="0" anchor="t">
             <a:spAutoFit/>
           </a:bodyPr>
           <a:lstStyle/>

</xml_diff>